<commit_message>
v2.9: fix -6% soft-trigger wording; add exposure-matched benchmark (sec 4.10/5.4) - S -7.3%/1.46 beats C -9.3%/1.19; conclusion revised to exposure>diversification>intervention; platform re-uploaded, CDN 919KB
</commit_message>
<xml_diff>
--- a/teaching_ppt/教学指导配套PPT_v2.pptx
+++ b/teaching_ppt/教学指导配套PPT_v2.pptx
@@ -19478,7 +19478,7 @@
                 <a:latin typeface="Hiragino Sans GB"/>
                 <a:ea typeface="Hiragino Sans GB"/>
               </a:rPr>
-              <a:t>·  统一硬约束：5bp 单边成本 · 6% 回撤预算 · 20% 个股上限</a:t>
+              <a:t>·  统一约束：5bp 单边成本 · 20% 个股上限（硬）· 6% 回撤软触线</a:t>
             </a:r>
           </a:p>
         </p:txBody>
@@ -22016,7 +22016,7 @@
                 <a:latin typeface="Hiragino Sans GB"/>
                 <a:ea typeface="Hiragino Sans GB"/>
               </a:rPr>
-              <a:t>单一标的上限 20% · 总仓位上限 100% · 单边交易成本 5bp · 最大回撤预算 -6%（违反即方案无效）</a:t>
+              <a:t>硬约束：单票上限 20% · 总仓上限 100% · 单边成本 5bp ｜ 软触线：回撤 -6% 触发减半（不保证不突破）</a:t>
             </a:r>
           </a:p>
         </p:txBody>

</xml_diff>